<commit_message>
Update timeline comparison: baseline switched to 2025-09 initial plan, +9 months delta
Co-authored-by: peterli0913 <peterli0913@users.noreply.github.com>
</commit_message>
<xml_diff>
--- a/AI_推进汇报_2026上半年_v3.pptx
+++ b/AI_推进汇报_2026上半年_v3.pptx
@@ -8050,13 +8050,13 @@
               </a:lnSpc>
             </a:pPr>
             <a:r>
-              <a:rPr sz="1050" b="0">
+              <a:rPr sz="1000" b="0">
                 <a:solidFill>
                   <a:srgbClr val="2C3E50"/>
                 </a:solidFill>
                 <a:latin typeface="微软雅黑"/>
               </a:rPr>
-              <a:t>整体开车目标 2027-06 → 2027-09，约 +3 个月；并非单一节点，而是设计阶段整体后移 5 个月带动的连锁传导</a:t>
+              <a:t>对比 2025-09 立项版初版计划，整体开车目标 2026-12 → 2027-09（+9 个月）；主因是业务需求扩展与深度对接 UK 工程/合规体系的必要投入</a:t>
             </a:r>
           </a:p>
         </p:txBody>
@@ -8205,7 +8205,7 @@
                 </a:solidFill>
                 <a:latin typeface="微软雅黑"/>
               </a:rPr>
-              <a:t>① 既有厂房升级改造 · 空间与消防受限</a:t>
+              <a:t>① 业务需求扩展 · 通用型反应器兼顾双工况</a:t>
             </a:r>
           </a:p>
         </p:txBody>
@@ -8289,7 +8289,7 @@
                 </a:solidFill>
                 <a:latin typeface="微软雅黑"/>
               </a:rPr>
-              <a:t>既有中试厂房改造，空间与中英防爆/消防规范双重受限；buffer tank 等设备多次调整，触发部分 HAZOP 重做</a:t>
+              <a:t>英方希望撬块同时覆盖高压与低压两类加氢工艺（以 129361 项目为蓝本），反应器与安全阀需含超临界/亚临界切换与双工况互斥保护，工程复杂度显著提升</a:t>
             </a:r>
           </a:p>
         </p:txBody>
@@ -8371,7 +8371,7 @@
                 </a:solidFill>
                 <a:latin typeface="微软雅黑"/>
               </a:rPr>
-              <a:t>② 深度技术议题 · 中英标准细节差异</a:t>
+              <a:t>② 既有厂房升级改造 · 空间与消防受限</a:t>
             </a:r>
           </a:p>
         </p:txBody>
@@ -8455,7 +8455,7 @@
                 </a:solidFill>
                 <a:latin typeface="微软雅黑"/>
               </a:rPr>
-              <a:t>泄放/超临界、清洗、分离器、控制与联锁等，中英思路与文档粒度不同，多个议题上升到科研级论证，耗时显著</a:t>
+              <a:t>既有中试厂房改造，空间与中英防爆/消防规范双重受限；Buffer Tank 等设备多次调整，触发部分 HAZOP 重做</a:t>
             </a:r>
           </a:p>
         </p:txBody>
@@ -8537,7 +8537,7 @@
                 </a:solidFill>
                 <a:latin typeface="微软雅黑"/>
               </a:rPr>
-              <a:t>③ 设计交付物范围扩展 · 匹配 UK 工程文档体系</a:t>
+              <a:t>③ 深度技术议题 · 中英标准细节差异</a:t>
             </a:r>
           </a:p>
         </p:txBody>
@@ -8621,7 +8621,7 @@
                 </a:solidFill>
                 <a:latin typeface="微软雅黑"/>
               </a:rPr>
-              <a:t>对比初版 35 项，现扩展至 55+ 项，新增 FDS/SDS/HDS、I/O Schedule、SIL/LOPA、Cable Schedule 等</a:t>
+              <a:t>泄放/超临界、清洗、分离器、控制与联锁等，中英思路与文档粒度不同，多项议题上升到科研级论证</a:t>
             </a:r>
           </a:p>
         </p:txBody>
@@ -8703,7 +8703,7 @@
                 </a:solidFill>
                 <a:latin typeface="微软雅黑"/>
               </a:rPr>
-              <a:t>④ 三方协作机制沉淀 · 前期必要投入</a:t>
+              <a:t>④ 设计交付物范围扩展 · 匹配 UK 工程文档体系</a:t>
             </a:r>
           </a:p>
         </p:txBody>
@@ -8787,7 +8787,7 @@
                 </a:solidFill>
                 <a:latin typeface="微软雅黑"/>
               </a:rPr>
-              <a:t>CFCT/IEPE/UK 三方跨语言协作基线建立，双方合并 92 项问题（33+59）系统闭环，降低后续返工</a:t>
+              <a:t>初版 19 项主要交付项扩展至 55+ 项，新增 FDS/SDS/HDS、I/O Schedule、SIL/LOPA、Cable Schedule 等</a:t>
             </a:r>
           </a:p>
         </p:txBody>
@@ -8869,7 +8869,7 @@
                 </a:solidFill>
                 <a:latin typeface="微软雅黑"/>
               </a:rPr>
-              <a:t>⑤ 采购与 CE 认证前置 · 依赖设计冻结</a:t>
+              <a:t>⑤ HAZOP 前风险系统闭环 + CE 与 NB 排期</a:t>
             </a:r>
           </a:p>
         </p:txBody>
@@ -8953,7 +8953,7 @@
                 </a:solidFill>
                 <a:latin typeface="微软雅黑"/>
               </a:rPr>
-              <a:t>长周期物料需等关键设计冻结再下 PO；CE-MD 范围/PED/ATEX 与 NB 反复对齐，较初版延长约 2-3 个月</a:t>
+              <a:t>92 项风险清单（33+59）系统闭环换 HAZOP 一次通过；CE-MD/PED/ATEX 与欧盟公告机构 NB 反复对齐并受排期约束</a:t>
             </a:r>
           </a:p>
         </p:txBody>

</xml_diff>